<commit_message>
Portrelo: logo op de cover en doelgroep uit hun eigen site
De cover noemt nu communicatieteams, zorginstellingen en gemeenten
en spreekt over demo's, de term die Portrelo zelf gebruikt. De
bellijst-bouwsteen beschrijft dezelfde doelgroep, gekoppeld aan
het aantoonbaar vastleggen van toestemming voor beeldgebruik.

Co-Authored-By: Claude Opus 5 <noreply@anthropic.com>
Claude-Session: https://claude.ai/code/session_0141FN3f3hHkYQHTyvTJJGrw
</commit_message>
<xml_diff>
--- a/output/LINK. kennismaking Portrelo.pptx
+++ b/output/LINK. kennismaking Portrelo.pptx
@@ -2519,7 +2519,7 @@
                 <a:ea typeface="Arial" pitchFamily="34" charset="-122"/>
                 <a:cs typeface="Arial" pitchFamily="34" charset="-120"/>
               </a:rPr>
-              <a:t>Wat LINK. voor Portrelo kan betekenen: in de maanden voor de lancering ontdekken wie op dit product zit te wachten en wat de markt ervan vindt, zodat er in januari al afspraken staan.</a:t>
+              <a:t>Wat LINK. voor Portrelo kan betekenen: in de maanden voor de lancering aan tafel bij communicatieteams, zorginstellingen en gemeenten, zodat er in januari al demo's in de agenda staan.</a:t>
             </a:r>
             <a:endParaRPr lang="en-US" sz="1400" dirty="0"/>
           </a:p>
@@ -2626,7 +2626,7 @@
         <p:spPr>
           <a:xfrm>
             <a:off x="1854195" y="5714986"/>
-            <a:ext cx="1396997" cy="406399"/>
+            <a:ext cx="1534579" cy="406399"/>
           </a:xfrm>
           <a:prstGeom prst="roundRect">
             <a:avLst>
@@ -2639,45 +2639,30 @@
           <a:ln/>
         </p:spPr>
       </p:sp>
-      <p:sp>
-        <p:nvSpPr>
-          <p:cNvPr id="33" name="Text 31"/>
-          <p:cNvSpPr txBox="1"/>
-          <p:nvPr/>
-        </p:nvSpPr>
-        <p:spPr>
-          <a:xfrm>
-            <a:off x="1854195" y="5714986"/>
-            <a:ext cx="1396997" cy="406399"/>
-          </a:xfrm>
-          <a:prstGeom prst="rect">
-            <a:avLst/>
-          </a:prstGeom>
-          <a:noFill/>
-          <a:ln/>
-        </p:spPr>
-        <p:txBody>
-          <a:bodyPr wrap="square" lIns="0" tIns="0" rIns="0" bIns="0" rtlCol="0" anchor="ctr"/>
-          <a:lstStyle/>
-          <a:p>
-            <a:pPr algn="ctr" indent="0" marL="0">
-              <a:buNone/>
-            </a:pPr>
-            <a:r>
-              <a:rPr lang="en-US" sz="1500" b="1" dirty="0">
-                <a:solidFill>
-                  <a:srgbClr val="1C2230"/>
-                </a:solidFill>
-                <a:latin typeface="Arial" pitchFamily="34" charset="0"/>
-                <a:ea typeface="Arial" pitchFamily="34" charset="-122"/>
-                <a:cs typeface="Arial" pitchFamily="34" charset="-120"/>
-              </a:rPr>
-              <a:t>Portrelo</a:t>
-            </a:r>
-            <a:endParaRPr lang="en-US" sz="1500" dirty="0"/>
-          </a:p>
-        </p:txBody>
-      </p:sp>
+      <p:pic>
+        <p:nvPicPr>
+          <p:cNvPr id="33" name="Image 0" descr="preencoded.png">    </p:cNvPr>
+          <p:cNvPicPr>
+            <a:picLocks noChangeAspect="1"/>
+          </p:cNvPicPr>
+          <p:nvPr/>
+        </p:nvPicPr>
+        <p:blipFill>
+          <a:blip r:embed="rId1"/>
+          <a:stretch>
+            <a:fillRect/>
+          </a:stretch>
+        </p:blipFill>
+        <p:spPr>
+          <a:xfrm>
+            <a:off x="2031995" y="5791186"/>
+            <a:ext cx="1178980" cy="253999"/>
+          </a:xfrm>
+          <a:prstGeom prst="rect">
+            <a:avLst/>
+          </a:prstGeom>
+        </p:spPr>
+      </p:pic>
     </p:spTree>
   </p:cSld>
   <p:clrMapOvr>
@@ -7756,7 +7741,7 @@
                 <a:ea typeface="Arial" pitchFamily="34" charset="-122"/>
                 <a:cs typeface="Arial" pitchFamily="34" charset="-120"/>
               </a:rPr>
-              <a:t>Wij bouwen de bellijst op jullie ideale klant: branche, grootte, regio en functie. Bestaande relaties en uitsluitingen gaan er vooraf uit.</a:t>
+              <a:t>Wij bouwen de bellijst op jullie ideale klant: communicatieteams, zorginstellingen en gemeenten die beeld publiceren en toestemming aantoonbaar moeten vastleggen.</a:t>
             </a:r>
             <a:endParaRPr lang="en-US" sz="875" dirty="0"/>
           </a:p>
@@ -8390,7 +8375,7 @@
                 <a:ea typeface="Arial" pitchFamily="34" charset="-122"/>
                 <a:cs typeface="Arial" pitchFamily="34" charset="-120"/>
               </a:rPr>
-              <a:t>Bellijst op jullie ideale klant</a:t>
+              <a:t>Bellijst met communicatie, zorg en overheid</a:t>
             </a:r>
             <a:endParaRPr lang="en-US" sz="900" dirty="0"/>
           </a:p>

</xml_diff>